<commit_message>
chore: minify agent prompts for extreme token efficiency and deploy offline logo verification
</commit_message>
<xml_diff>
--- a/VaaniGuard_teamhatsoff.pptx
+++ b/VaaniGuard_teamhatsoff.pptx
@@ -4817,24 +4817,74 @@
           <a:bodyPr wrap="square" rtlCol="0" anchor="ctr"/>
           <a:lstStyle/>
           <a:p>
-            <a:pPr marL="0" indent="0">
+            <a:pPr>
               <a:lnSpc>
                 <a:spcPct val="125000"/>
               </a:lnSpc>
-              <a:buNone/>
-            </a:pPr>
-            <a:r>
-              <a:rPr lang="en-US" sz="1250" dirty="0">
-                <a:solidFill>
-                  <a:srgbClr val="5B6079"/>
-                </a:solidFill>
-                <a:latin typeface="Inter" pitchFamily="34" charset="0"/>
-                <a:ea typeface="Inter" pitchFamily="34" charset="-122"/>
-                <a:cs typeface="Inter" pitchFamily="34" charset="-120"/>
-              </a:rPr>
-              <a:t>Before the AI analyzes the message, our Python backend intercepts the text and maps phonetic misspellings to their canonical roots.</a:t>
-            </a:r>
-            <a:endParaRPr lang="en-US" sz="1250" dirty="0"/>
+            </a:pPr>
+            <a:r>
+              <a:rPr lang="en-IN" sz="1250" dirty="0">
+                <a:solidFill>
+                  <a:schemeClr val="bg1">
+                    <a:lumMod val="50000"/>
+                  </a:schemeClr>
+                </a:solidFill>
+                <a:latin typeface="Inter"/>
+              </a:rPr>
+              <a:t>Before the AI </a:t>
+            </a:r>
+            <a:r>
+              <a:rPr lang="en-IN" sz="1250" dirty="0" err="1">
+                <a:solidFill>
+                  <a:schemeClr val="bg1">
+                    <a:lumMod val="50000"/>
+                  </a:schemeClr>
+                </a:solidFill>
+                <a:latin typeface="Inter"/>
+              </a:rPr>
+              <a:t>analyzes</a:t>
+            </a:r>
+            <a:r>
+              <a:rPr lang="en-IN" sz="1250" dirty="0">
+                <a:solidFill>
+                  <a:schemeClr val="bg1">
+                    <a:lumMod val="50000"/>
+                  </a:schemeClr>
+                </a:solidFill>
+                <a:latin typeface="Inter"/>
+              </a:rPr>
+              <a:t> the message, our </a:t>
+            </a:r>
+            <a:r>
+              <a:rPr lang="en-IN" sz="1250" b="1" dirty="0">
+                <a:solidFill>
+                  <a:schemeClr val="bg1">
+                    <a:lumMod val="50000"/>
+                  </a:schemeClr>
+                </a:solidFill>
+                <a:latin typeface="Inter"/>
+              </a:rPr>
+              <a:t>Node.js / Express backend</a:t>
+            </a:r>
+            <a:r>
+              <a:rPr lang="en-IN" sz="1250" dirty="0">
+                <a:solidFill>
+                  <a:schemeClr val="bg1">
+                    <a:lumMod val="50000"/>
+                  </a:schemeClr>
+                </a:solidFill>
+                <a:latin typeface="Inter"/>
+              </a:rPr>
+              <a:t> intercepts the raw payload and maps phonetic misspellings to their canonical roots.</a:t>
+            </a:r>
+            <a:endParaRPr lang="en-US" sz="1250" dirty="0">
+              <a:solidFill>
+                <a:schemeClr val="bg1">
+                  <a:lumMod val="50000"/>
+                </a:schemeClr>
+              </a:solidFill>
+              <a:latin typeface="Inter"/>
+            </a:endParaRPr>
           </a:p>
         </p:txBody>
       </p:sp>
@@ -9059,24 +9109,41 @@
           <a:bodyPr wrap="square" rtlCol="0" anchor="ctr"/>
           <a:lstStyle/>
           <a:p>
-            <a:pPr marL="0" indent="0">
+            <a:pPr>
               <a:lnSpc>
                 <a:spcPct val="125000"/>
               </a:lnSpc>
-              <a:buNone/>
-            </a:pPr>
-            <a:r>
-              <a:rPr lang="en-US" sz="1150" dirty="0">
-                <a:solidFill>
-                  <a:srgbClr val="5B6079"/>
-                </a:solidFill>
-                <a:latin typeface="Inter" pitchFamily="34" charset="0"/>
-                <a:ea typeface="Inter" pitchFamily="34" charset="-122"/>
-                <a:cs typeface="Inter" pitchFamily="34" charset="-120"/>
-              </a:rPr>
-              <a:t>Python — FastAPI / Express.</a:t>
-            </a:r>
-            <a:endParaRPr lang="en-US" sz="1150" dirty="0"/>
+            </a:pPr>
+            <a:r>
+              <a:rPr lang="en-IN" sz="1150" b="1" dirty="0">
+                <a:solidFill>
+                  <a:schemeClr val="bg1">
+                    <a:lumMod val="50000"/>
+                  </a:schemeClr>
+                </a:solidFill>
+                <a:latin typeface="Inter"/>
+              </a:rPr>
+              <a:t>Node.js / Express</a:t>
+            </a:r>
+            <a:r>
+              <a:rPr lang="en-IN" sz="1150" dirty="0">
+                <a:solidFill>
+                  <a:schemeClr val="bg1">
+                    <a:lumMod val="50000"/>
+                  </a:schemeClr>
+                </a:solidFill>
+                <a:latin typeface="Inter"/>
+              </a:rPr>
+              <a:t> — Lightweight, high-throughput asynchronous backend managing the phonetic normalizer, regex heuristic engine, and multi-agent pipeline.</a:t>
+            </a:r>
+            <a:endParaRPr lang="en-US" sz="1150" dirty="0">
+              <a:solidFill>
+                <a:schemeClr val="bg1">
+                  <a:lumMod val="50000"/>
+                </a:schemeClr>
+              </a:solidFill>
+              <a:latin typeface="Inter"/>
+            </a:endParaRPr>
           </a:p>
         </p:txBody>
       </p:sp>
@@ -9381,24 +9448,63 @@
           <a:bodyPr wrap="square" rtlCol="0" anchor="ctr"/>
           <a:lstStyle/>
           <a:p>
-            <a:pPr marL="0" indent="0">
+            <a:pPr>
               <a:lnSpc>
                 <a:spcPct val="125000"/>
               </a:lnSpc>
-              <a:buNone/>
-            </a:pPr>
-            <a:r>
-              <a:rPr lang="en-US" sz="1150" dirty="0">
-                <a:solidFill>
-                  <a:srgbClr val="5B6079"/>
-                </a:solidFill>
-                <a:latin typeface="Inter" pitchFamily="34" charset="0"/>
-                <a:ea typeface="Inter" pitchFamily="34" charset="-122"/>
-                <a:cs typeface="Inter" pitchFamily="34" charset="-120"/>
-              </a:rPr>
-              <a:t>Asynchronous parallel processing (asyncio) — the 3-agent pipeline resolves in milliseconds without freezing the UI.</a:t>
-            </a:r>
-            <a:endParaRPr lang="en-US" sz="1150" dirty="0"/>
+            </a:pPr>
+            <a:r>
+              <a:rPr lang="en-IN" sz="1150" b="1" dirty="0">
+                <a:solidFill>
+                  <a:schemeClr val="bg1">
+                    <a:lumMod val="50000"/>
+                  </a:schemeClr>
+                </a:solidFill>
+                <a:latin typeface="Inter"/>
+              </a:rPr>
+              <a:t>Concurrent Async Execution (</a:t>
+            </a:r>
+            <a:r>
+              <a:rPr lang="en-IN" sz="1150" b="1" dirty="0" err="1">
+                <a:solidFill>
+                  <a:schemeClr val="bg1">
+                    <a:lumMod val="50000"/>
+                  </a:schemeClr>
+                </a:solidFill>
+                <a:latin typeface="Inter"/>
+              </a:rPr>
+              <a:t>Promise.all</a:t>
+            </a:r>
+            <a:r>
+              <a:rPr lang="en-IN" sz="1150" b="1" dirty="0">
+                <a:solidFill>
+                  <a:schemeClr val="bg1">
+                    <a:lumMod val="50000"/>
+                  </a:schemeClr>
+                </a:solidFill>
+                <a:latin typeface="Inter"/>
+              </a:rPr>
+              <a:t>)</a:t>
+            </a:r>
+            <a:r>
+              <a:rPr lang="en-IN" sz="1150" dirty="0">
+                <a:solidFill>
+                  <a:schemeClr val="bg1">
+                    <a:lumMod val="50000"/>
+                  </a:schemeClr>
+                </a:solidFill>
+                <a:latin typeface="Inter"/>
+              </a:rPr>
+              <a:t> — Leverages Node.js's non-blocking event loop to resolve parallel agent investigations simultaneously in milliseconds without freezing the client UI</a:t>
+            </a:r>
+            <a:endParaRPr lang="en-US" sz="1150" dirty="0">
+              <a:solidFill>
+                <a:schemeClr val="bg1">
+                  <a:lumMod val="50000"/>
+                </a:schemeClr>
+              </a:solidFill>
+              <a:latin typeface="Inter"/>
+            </a:endParaRPr>
           </a:p>
         </p:txBody>
       </p:sp>

</xml_diff>